<commit_message>
Upgrade universal PPT benchmark and seed pipeline
Document generation-evaluation closed loop, add DeckIR/universal scorecard and seed pipeline modules, and patch golden baseline2 cover SIGNAL text.
</commit_message>
<xml_diff>
--- a/outputs/golden_baselines/golden_baseline2_blind_rectangular_research_board/DeepResidual_20260630_blind_rectangular_golden2_reference.pptx
+++ b/outputs/golden_baselines/golden_baseline2_blind_rectangular_research_board/DeepResidual_20260630_blind_rectangular_golden2_reference.pptx
@@ -3934,12 +3934,18 @@
           <a:noFill/>
         </p:spPr>
         <p:txBody>
-          <a:bodyPr wrap="square" lIns="18288" rIns="18288" tIns="9144" bIns="9144">
+          <a:bodyPr wrap="square" lIns="0" rIns="0" tIns="0" bIns="0" anchor="ctr">
             <a:normAutofit/>
           </a:bodyPr>
           <a:lstStyle/>
           <a:p>
-            <a:pPr>
+            <a:pPr algn="l">
+              <a:spcBef>
+                <a:spcPts val="0"/>
+              </a:spcBef>
+              <a:spcAft>
+                <a:spcPts val="0"/>
+              </a:spcAft>
               <a:defRPr sz="1250" b="1">
                 <a:solidFill>
                   <a:srgbClr val="18221D"/>
@@ -3947,6 +3953,15 @@
                 <a:latin typeface="Aptos"/>
               </a:defRPr>
             </a:pPr>
+            <a:r>
+              <a:rPr sz="1300" b="0">
+                <a:solidFill>
+                  <a:srgbClr val="272D33"/>
+                </a:solidFill>
+                <a:latin typeface="Aptos"/>
+              </a:rPr>
+              <a:t>Claim-first cards expose the problem, method, and evidence path.</a:t>
+            </a:r>
           </a:p>
         </p:txBody>
       </p:sp>
@@ -4093,12 +4108,18 @@
           <a:noFill/>
         </p:spPr>
         <p:txBody>
-          <a:bodyPr wrap="square" lIns="18288" rIns="18288" tIns="9144" bIns="9144">
+          <a:bodyPr wrap="square" lIns="0" rIns="0" tIns="0" bIns="0" anchor="ctr">
             <a:normAutofit/>
           </a:bodyPr>
           <a:lstStyle/>
           <a:p>
-            <a:pPr>
+            <a:pPr algn="l">
+              <a:spcBef>
+                <a:spcPts val="0"/>
+              </a:spcBef>
+              <a:spcAft>
+                <a:spcPts val="0"/>
+              </a:spcAft>
               <a:defRPr sz="1250" b="1">
                 <a:solidFill>
                   <a:srgbClr val="18221D"/>
@@ -4106,6 +4127,15 @@
                 <a:latin typeface="Aptos"/>
               </a:defRPr>
             </a:pPr>
+            <a:r>
+              <a:rPr sz="1300" b="0">
+                <a:solidFill>
+                  <a:srgbClr val="272D33"/>
+                </a:solidFill>
+                <a:latin typeface="Aptos"/>
+              </a:rPr>
+              <a:t>Source figures and tables stay traceable inside editable proof panels.</a:t>
+            </a:r>
           </a:p>
         </p:txBody>
       </p:sp>
@@ -4252,12 +4282,18 @@
           <a:noFill/>
         </p:spPr>
         <p:txBody>
-          <a:bodyPr wrap="square" lIns="18288" rIns="18288" tIns="9144" bIns="9144">
+          <a:bodyPr wrap="square" lIns="0" rIns="0" tIns="0" bIns="0" anchor="ctr">
             <a:normAutofit/>
           </a:bodyPr>
           <a:lstStyle/>
           <a:p>
-            <a:pPr>
+            <a:pPr algn="l">
+              <a:spcBef>
+                <a:spcPts val="0"/>
+              </a:spcBef>
+              <a:spcAft>
+                <a:spcPts val="0"/>
+              </a:spcAft>
               <a:defRPr sz="1250" b="1">
                 <a:solidFill>
                   <a:srgbClr val="18221D"/>
@@ -4265,6 +4301,15 @@
                 <a:latin typeface="Aptos"/>
               </a:defRPr>
             </a:pPr>
+            <a:r>
+              <a:rPr sz="1300" b="0">
+                <a:solidFill>
+                  <a:srgbClr val="272D33"/>
+                </a:solidFill>
+                <a:latin typeface="Aptos"/>
+              </a:rPr>
+              <a:t>Nonvisual audit converts layout defects into scoped repair rules.</a:t>
+            </a:r>
           </a:p>
         </p:txBody>
       </p:sp>

</xml_diff>